<commit_message>
docs: actualiza informe PDF y presentacion PPTX a la arquitectura actual
- Informe Tecnico VeloUrbe.pdf regenerado: 10 microservicios funcionales,
  flujo Gateway -> BFF -> microservicios, tabla completa de servicios y BDs,
  diagramas C2/C3 actualizados (C3 con patron CSR), RF nuevos (pagos,
  estaciones, resenas, BFF proxy), Swagger centralizado y estrategia Git
  con los 12 servicios.
- Presentacion VeloUrbe.pptx actualizada (mismo diseno): portada, contexto,
  arquitectura, diagramas C2, Swagger centralizado, branching y conclusion
  reflejan los 10 microservicios y el Gateway sin codigo.
</commit_message>
<xml_diff>
--- a/Presentacion VeloUrbe.pptx
+++ b/Presentacion VeloUrbe.pptx
@@ -3510,7 +3510,7 @@
                 </a:solidFill>
                 <a:latin typeface="Calibri"/>
               </a:rPr>
-              <a:t>Spring Boot 3.5  ·  Java 21  ·  Docker  ·  PostgreSQL  ·  JWT  ·  API Gateway + BFF</a:t>
+              <a:t>Spring Boot 3.5 · Java 21 · Docker · PostgreSQL · JWT · Gateway → BFF → 10 Microservicios</a:t>
             </a:r>
           </a:p>
           <a:p>
@@ -5308,7 +5308,7 @@
                 </a:solidFill>
                 <a:latin typeface="Calibri"/>
               </a:rPr>
-              <a:t>Cobertura por servicio (8 clases de test)</a:t>
+              <a:t>Cobertura por servicio (11 clases de test)</a:t>
             </a:r>
           </a:p>
         </p:txBody>
@@ -5908,7 +5908,7 @@
                 </a:solidFill>
                 <a:latin typeface="Calibri"/>
               </a:rPr>
-              <a:t>Cada microservicio expone su documentación interactiva con SpringDoc OpenAPI. El JSON se exporta e importa en Postman para la colección de pruebas.</a:t>
+              <a:t>Swagger centralizado en el Gateway agrupa la documentación de los 11 servicios; además cada microservicio expone su propio Swagger UI (SpringDoc OpenAPI).</a:t>
             </a:r>
           </a:p>
         </p:txBody>
@@ -6047,7 +6047,7 @@
                 </a:solidFill>
                 <a:latin typeface="Calibri"/>
               </a:rPr>
-              <a:t>user-auth-service</a:t>
+              <a:t>Swagger centralizado — Gateway</a:t>
             </a:r>
           </a:p>
         </p:txBody>
@@ -6089,7 +6089,7 @@
                 </a:solidFill>
                 <a:latin typeface="Calibri"/>
               </a:rPr>
-              <a:t>localhost:8081/swagger-ui.html</a:t>
+              <a:t>localhost:8080/swagger-ui.html</a:t>
             </a:r>
           </a:p>
         </p:txBody>
@@ -6228,7 +6228,7 @@
                 </a:solidFill>
                 <a:latin typeface="Calibri"/>
               </a:rPr>
-              <a:t>scooter-rental-service</a:t>
+              <a:t>10 microservicios de dominio</a:t>
             </a:r>
           </a:p>
         </p:txBody>
@@ -6270,7 +6270,7 @@
                 </a:solidFill>
                 <a:latin typeface="Calibri"/>
               </a:rPr>
-              <a:t>localhost:8082/swagger-ui.html</a:t>
+              <a:t>localhost:8081…8091/swagger-ui.html</a:t>
             </a:r>
           </a:p>
         </p:txBody>
@@ -7181,7 +7181,7 @@
                 </a:solidFill>
                 <a:latin typeface="Calibri"/>
               </a:rPr>
-              <a:t>Rama estable y siempre desplegable. Contiene la versión integrada de los 4 servicios.</a:t>
+              <a:t>Rama estable y siempre desplegable. Contiene la versión integrada de los 12 servicios.</a:t>
             </a:r>
           </a:p>
         </p:txBody>
@@ -13117,7 +13117,7 @@
                 </a:solidFill>
                 <a:latin typeface="Calibri"/>
               </a:rPr>
-              <a:t>La segregación funcional en microservicios, coordinada por un API Gateway y optimizada con un BFF, produce un sistema cohesivo, desacoplado y tolerante a fallos.</a:t>
+              <a:t>La segregación en 10 microservicios, coordinada por un API Gateway que enruta al BFF (patrón Gateway → BFF → servicios), produce un sistema cohesivo, desacoplado y tolerante a fallos.</a:t>
             </a:r>
           </a:p>
           <a:p>
@@ -13238,7 +13238,7 @@
                 </a:solidFill>
                 <a:latin typeface="Calibri"/>
               </a:rPr>
-              <a:t>Microservicios + BFF + Gateway</a:t>
+              <a:t>10 Microservicios + BFF + Gateway</a:t>
             </a:r>
           </a:p>
         </p:txBody>
@@ -13850,7 +13850,7 @@
                 </a:solidFill>
                 <a:latin typeface="Calibri"/>
               </a:rPr>
-              <a:t>Swagger + Postman</a:t>
+              <a:t>Swagger centralizado + Postman</a:t>
             </a:r>
           </a:p>
         </p:txBody>
@@ -14294,7 +14294,7 @@
                 </a:solidFill>
                 <a:latin typeface="Calibri"/>
               </a:rPr>
-              <a:t>VeloUrbe resuelve la movilidad urbana de última milla con un ecosistema digital que permite arrendar patinetas eléctricas de forma ágil y segura. Adopta una arquitectura de microservicios para desacoplar la gestión de identidades, el inventario de flota y la experiencia del cliente.</a:t>
+              <a:t>VeloUrbe resuelve la movilidad urbana de última milla con un ecosistema digital que permite arrendar patinetas eléctricas de forma ágil y segura. Adopta una arquitectura de 10 microservicios tras un API Gateway y un BFF para desacoplar identidades, flota, pagos y la experiencia del cliente.</a:t>
             </a:r>
           </a:p>
         </p:txBody>
@@ -14690,7 +14690,7 @@
                 </a:solidFill>
                 <a:latin typeface="Calibri"/>
               </a:rPr>
-              <a:t>Ecosistema de 4 servicios</a:t>
+              <a:t>10 microservicios de dominio</a:t>
             </a:r>
           </a:p>
           <a:p>
@@ -14709,7 +14709,7 @@
                 </a:solidFill>
                 <a:latin typeface="Calibri"/>
               </a:rPr>
-              <a:t>desacoplados, orquestados</a:t>
+              <a:t>tras un Gateway y un BFF,</a:t>
             </a:r>
           </a:p>
           <a:p>
@@ -18303,7 +18303,7 @@
                 </a:solidFill>
                 <a:latin typeface="Calibri"/>
               </a:rPr>
-              <a:t>El cliente envía credenciales al Gateway → se enrutan al servicio de auth → se hashean y persisten → retorna un JWT que habilita el acceso a los módulos protegidos.</a:t>
+              <a:t>El cliente envía credenciales al Gateway → pasan por el BFF al servicio de auth → se hashean y persisten → retorna un JWT que habilita el acceso a los módulos protegidos.</a:t>
             </a:r>
           </a:p>
         </p:txBody>
@@ -19269,7 +19269,7 @@
                 </a:solidFill>
                 <a:latin typeface="Calibri"/>
               </a:rPr>
-              <a:t>Punto de entrada único.</a:t>
+              <a:t>Punto de entrada único, sin código.</a:t>
             </a:r>
           </a:p>
           <a:p>
@@ -19288,7 +19288,7 @@
                 </a:solidFill>
                 <a:latin typeface="Calibri"/>
               </a:rPr>
-              <a:t>Enrutamiento, CORS y logging perimetral.</a:t>
+              <a:t>Solo configuración: enruta /api/** al BFF.</a:t>
             </a:r>
           </a:p>
         </p:txBody>
@@ -20230,7 +20230,7 @@
                 </a:solidFill>
                 <a:latin typeface="Calibri"/>
               </a:rPr>
-              <a:t>Agrega datos vía WebClient.</a:t>
+              <a:t>Proxy + agregación a los 10 servicios.</a:t>
             </a:r>
           </a:p>
         </p:txBody>
@@ -20351,7 +20351,7 @@
                 </a:solidFill>
                 <a:latin typeface="Calibri"/>
               </a:rPr>
-              <a:t>Cada servicio es un Bounded Context independiente con su propia base de datos PostgreSQL (Database per Service).</a:t>
+              <a:t>10 microservicios de dominio (8081–8091): auth, rental, payment, notification, analytics, logistics, maintenance, support, station y review — cada uno con su BD PostgreSQL (Database per Service).</a:t>
             </a:r>
           </a:p>
         </p:txBody>
@@ -20864,7 +20864,7 @@
                 </a:solidFill>
                 <a:latin typeface="Calibri"/>
               </a:rPr>
-              <a:t>Entrada única · Enrutamiento · CORS · Logging</a:t>
+              <a:t>Entrada única · Solo configuración · CORS · /api/** → BFF</a:t>
             </a:r>
           </a:p>
         </p:txBody>
@@ -21230,7 +21230,7 @@
                 </a:solidFill>
                 <a:latin typeface="Calibri"/>
               </a:rPr>
-              <a:t>Dashboard / Resumen (WebClient)</a:t>
+              <a:t>Proxy + Dashboard (WebClient)</a:t>
             </a:r>
           </a:p>
         </p:txBody>
@@ -21592,7 +21592,7 @@
                 </a:solidFill>
                 <a:latin typeface="Calibri"/>
               </a:rPr>
-              <a:t>BFF consume Auth + Rental vía WebClient</a:t>
+              <a:t>Gateway → BFF → 10 microservicios (8081–8091)</a:t>
             </a:r>
           </a:p>
         </p:txBody>

</xml_diff>

<commit_message>
docs: actualiza al completo las diapositivas restantes de la presentacion (RF, RNF, C3 CSR, BD, tests, git, demo)
</commit_message>
<xml_diff>
--- a/Presentacion VeloUrbe.pptx
+++ b/Presentacion VeloUrbe.pptx
@@ -3829,7 +3829,7 @@
                 </a:solidFill>
                 <a:latin typeface="Calibri"/>
               </a:rPr>
-              <a:t>Cada microservicio tiene su propia base de datos PostgreSQL. Flyway versiona el esquema con DDL separado del DML.</a:t>
+              <a:t>Cada uno de los 10 microservicios tiene su propia BD PostgreSQL (incluidas db_scooter_stations y db_scooter_reviews). Flyway versiona el esquema con DDL separado del DML.</a:t>
             </a:r>
           </a:p>
         </p:txBody>
@@ -5449,7 +5449,7 @@
                 </a:solidFill>
                 <a:latin typeface="Calibri"/>
               </a:rPr>
-              <a:t>scooter-rental-service</a:t>
+              <a:t>rental / station / review</a:t>
             </a:r>
           </a:p>
           <a:p>
@@ -5468,7 +5468,7 @@
                 </a:solidFill>
                 <a:latin typeface="Calibri"/>
               </a:rPr>
-              <a:t>ScooterServiceTest · RentalServiceTest</a:t>
+              <a:t>ScooterServiceTest · RentalServiceTest · StationServiceTest</a:t>
             </a:r>
           </a:p>
           <a:p>
@@ -5487,7 +5487,7 @@
                 </a:solidFill>
                 <a:latin typeface="Calibri"/>
               </a:rPr>
-              <a:t>ScooterControllerTest · RentalControllerTest</a:t>
+              <a:t>ReviewServiceTest · Scooter/RentalControllerTest</a:t>
             </a:r>
           </a:p>
           <a:p>
@@ -5506,7 +5506,7 @@
                 </a:solidFill>
                 <a:latin typeface="Calibri"/>
               </a:rPr>
-              <a:t>Crear/listar/eliminar, iniciar/finalizar arriendo…</a:t>
+              <a:t>Arriendos, dock/undock de estaciones, rating promedio…</a:t>
             </a:r>
           </a:p>
         </p:txBody>
@@ -7336,7 +7336,7 @@
                 </a:solidFill>
                 <a:latin typeface="Calibri"/>
               </a:rPr>
-              <a:t>Una rama por funcionalidad (auth, rentals, bff, gateway). Se mergea a main por PR.</a:t>
+              <a:t>Una rama por funcionalidad (auth, rentals, stations, reviews…). Se mergea a main por PR.</a:t>
             </a:r>
           </a:p>
         </p:txBody>
@@ -7979,7 +7979,7 @@
                 </a:solidFill>
                 <a:latin typeface="Calibri"/>
               </a:rPr>
-              <a:t>Todo el ecosistema corre localmente con Docker Desktop (incluida la BD PostgreSQL en contenedor).</a:t>
+              <a:t>Los 13 contenedores corren localmente con Docker: Gateway → BFF → 10 microservicios + PostgreSQL.</a:t>
             </a:r>
           </a:p>
         </p:txBody>
@@ -16107,7 +16107,7 @@
                 </a:solidFill>
                 <a:latin typeface="Calibri"/>
               </a:rPr>
-              <a:t>Lógica transaccional para iniciar y finalizar viajes, con marcas de tiempo y duración total.</a:t>
+              <a:t>Viajes transaccionales con marcas de tiempo y duración; al finalizar: pago y reseña del arriendo.</a:t>
             </a:r>
           </a:p>
         </p:txBody>
@@ -16260,7 +16260,7 @@
                 </a:solidFill>
                 <a:latin typeface="Calibri"/>
               </a:rPr>
-              <a:t>BFF Dashboard</a:t>
+              <a:t>BFF Proxy + Dashboard</a:t>
             </a:r>
           </a:p>
         </p:txBody>
@@ -16302,7 +16302,7 @@
                 </a:solidFill>
                 <a:latin typeface="Calibri"/>
               </a:rPr>
-              <a:t>Agregación de perfil, flota disponible y arriendos activos en una única petición de red.</a:t>
+              <a:t>Proxy de /api/** hacia los 10 microservicios y agregación de perfil, flota y arriendos en una sola petición.</a:t>
             </a:r>
           </a:p>
         </p:txBody>
@@ -17386,7 +17386,7 @@
                 </a:solidFill>
                 <a:latin typeface="Calibri"/>
               </a:rPr>
-              <a:t>DTOs inmutables con Java Records y respuestas RESTful con convenciones HATEOAS.</a:t>
+              <a:t>Patrón CSR en los 10 servicios, DTOs inmutables (Records) y respuestas HATEOAS.</a:t>
             </a:r>
           </a:p>
         </p:txBody>
@@ -21892,7 +21892,7 @@
                 </a:solidFill>
                 <a:latin typeface="Calibri"/>
               </a:rPr>
-              <a:t>Diagrama C3 — Componentes (scooter-rental-service)</a:t>
+              <a:t>Diagrama C3 — Patrón CSR (scooter-rental-service)</a:t>
             </a:r>
           </a:p>
         </p:txBody>
@@ -22856,7 +22856,7 @@
                 </a:solidFill>
                 <a:latin typeface="Calibri"/>
               </a:rPr>
-              <a:t>• Controllers sin lógica de negocio (SRP).</a:t>
+              <a:t>• Controllers sin lógica ni repositorios (CSR verificado).</a:t>
             </a:r>
           </a:p>
         </p:txBody>
@@ -23012,7 +23012,7 @@
                 </a:solidFill>
                 <a:latin typeface="Calibri"/>
               </a:rPr>
-              <a:t>El BFF y los servicios se comunican entre sí intercambiando DTOs sobre HTTP.</a:t>
+              <a:t>El BFF proxea /api/** y agrega datos de los 10 microservicios sobre HTTP.</a:t>
             </a:r>
           </a:p>
           <a:p>

</xml_diff>